<commit_message>
Mejora la legibilidad del PowerPoint
</commit_message>
<xml_diff>
--- a/assets/presentations/2026-07-26-todo-hablaba-de-ti.pptx
+++ b/assets/presentations/2026-07-26-todo-hablaba-de-ti.pptx
@@ -2,15 +2,15 @@
 <file path=ppt/presentation.xml><?xml version="1.0" encoding="utf-8"?>
 <p:presentation xmlns:p="http://schemas.openxmlformats.org/presentationml/2006/main">
   <p:sldMasterIdLst>
-    <p:sldMasterId xmlns:r="http://schemas.openxmlformats.org/officeDocument/2006/relationships" id="2147483648" r:id="R3136edf18be348bc"/>
+    <p:sldMasterId xmlns:r="http://schemas.openxmlformats.org/officeDocument/2006/relationships" id="2147483648" r:id="Rf53feb853ad74b7b"/>
   </p:sldMasterIdLst>
   <p:notesMasterIdLst>
-    <p:notesMasterId xmlns:r="http://schemas.openxmlformats.org/officeDocument/2006/relationships" r:id="R49a9a2f78da44ead"/>
+    <p:notesMasterId xmlns:r="http://schemas.openxmlformats.org/officeDocument/2006/relationships" r:id="Rd12f3e867e454076"/>
   </p:notesMasterIdLst>
   <p:sldIdLst>
-    <p:sldId xmlns:r="http://schemas.openxmlformats.org/officeDocument/2006/relationships" id="256" r:id="R1eb40779b28a4463"/>
-    <p:sldId xmlns:r="http://schemas.openxmlformats.org/officeDocument/2006/relationships" id="257" r:id="R8b1229cb32bd42a1"/>
-    <p:sldId xmlns:r="http://schemas.openxmlformats.org/officeDocument/2006/relationships" id="258" r:id="R4399669b6d484941"/>
+    <p:sldId xmlns:r="http://schemas.openxmlformats.org/officeDocument/2006/relationships" id="256" r:id="R5e2561db2a564748"/>
+    <p:sldId xmlns:r="http://schemas.openxmlformats.org/officeDocument/2006/relationships" id="257" r:id="R5ba0308bae3347cf"/>
+    <p:sldId xmlns:r="http://schemas.openxmlformats.org/officeDocument/2006/relationships" id="258" r:id="R57a7fb8f18e1411e"/>
   </p:sldIdLst>
   <p:sldSz cx="12192000" cy="6858000"/>
   <p:notesSz cx="6858000" cy="9144000"/>
@@ -747,7 +747,7 @@
   </p:cSld>
   <p:clrMap bg1="lt1" tx1="dk1" bg2="lt2" tx2="dk2" accent1="accent1" accent2="accent2" accent3="accent3" accent4="accent4" accent5="accent5" accent6="accent6" hlink="hlink" folHlink="folHlink"/>
   <p:sldLayoutIdLst>
-    <p:sldLayoutId xmlns:r="http://schemas.openxmlformats.org/officeDocument/2006/relationships" id="2147483649" r:id="R82a0a647df084b99"/>
+    <p:sldLayoutId xmlns:r="http://schemas.openxmlformats.org/officeDocument/2006/relationships" id="2147483649" r:id="R6798532ddf1e4a8a"/>
   </p:sldLayoutIdLst>
   <p:txStyles>
     <p:titleStyle>
@@ -1288,14 +1288,14 @@
       </p:grpSpPr>
       <p:pic>
         <p:nvPicPr>
-          <p:cNvPr id="40" name=""/>
+          <p:cNvPr id="41" name=""/>
           <p:cNvPicPr>
             <a:picLocks xmlns:a="http://schemas.openxmlformats.org/drawingml/2006/main" noChangeAspect="1"/>
           </p:cNvPicPr>
           <p:nvPr/>
         </p:nvPicPr>
         <p:blipFill>
-          <a:blip xmlns:r="http://schemas.openxmlformats.org/officeDocument/2006/relationships" xmlns:a="http://schemas.openxmlformats.org/drawingml/2006/main" r:embed="Re522d80027cb420d"/>
+          <a:blip xmlns:r="http://schemas.openxmlformats.org/officeDocument/2006/relationships" xmlns:a="http://schemas.openxmlformats.org/drawingml/2006/main" r:embed="R97a21f9c8568483f"/>
           <a:srcRect xmlns:a="http://schemas.openxmlformats.org/drawingml/2006/main" l="0" t="27" r="0" b="27"/>
           <a:stretch xmlns:a="http://schemas.openxmlformats.org/drawingml/2006/main">
             <a:fillRect l="0" t="0" r="0" b="0"/>
@@ -1351,10 +1351,8 @@
               </a:lnSpc>
               <a:buNone/>
               <a:defRPr sz="2925" b="0" i="0">
-                <a:ln w="10478">
-                  <a:solidFill>
-                    <a:srgbClr val="071824"/>
-                  </a:solidFill>
+                <a:ln w="0">
+                  <a:noFill/>
                   <a:prstDash val="solid"/>
                 </a:ln>
                 <a:solidFill>
@@ -1367,10 +1365,8 @@
             </a:pPr>
             <a:r>
               <a:rPr sz="2925" b="0" i="0">
-                <a:ln w="10478">
-                  <a:solidFill>
-                    <a:srgbClr val="071824"/>
-                  </a:solidFill>
+                <a:ln w="0">
+                  <a:noFill/>
                   <a:prstDash val="solid"/>
                 </a:ln>
                 <a:solidFill>
@@ -1425,10 +1421,8 @@
               </a:lnSpc>
               <a:buNone/>
               <a:defRPr sz="1575" b="0" i="0">
-                <a:ln w="10478">
-                  <a:solidFill>
-                    <a:srgbClr val="071824"/>
-                  </a:solidFill>
+                <a:ln w="0">
+                  <a:noFill/>
                   <a:prstDash val="solid"/>
                 </a:ln>
                 <a:solidFill>
@@ -1441,10 +1435,8 @@
             </a:pPr>
             <a:r>
               <a:rPr sz="1575" b="0" i="0">
-                <a:ln w="10478">
-                  <a:solidFill>
-                    <a:srgbClr val="071824"/>
-                  </a:solidFill>
+                <a:ln w="0">
+                  <a:noFill/>
                   <a:prstDash val="solid"/>
                 </a:ln>
                 <a:solidFill>
@@ -1532,10 +1524,8 @@
               </a:lnSpc>
               <a:buNone/>
               <a:defRPr sz="2325" b="1" i="0">
-                <a:ln w="10478">
-                  <a:solidFill>
-                    <a:srgbClr val="071824"/>
-                  </a:solidFill>
+                <a:ln w="0">
+                  <a:noFill/>
                   <a:prstDash val="solid"/>
                 </a:ln>
                 <a:solidFill>
@@ -1548,10 +1538,8 @@
             </a:pPr>
             <a:r>
               <a:rPr sz="2325" b="1" i="0">
-                <a:ln w="10478">
-                  <a:solidFill>
-                    <a:srgbClr val="071824"/>
-                  </a:solidFill>
+                <a:ln w="0">
+                  <a:noFill/>
                   <a:prstDash val="solid"/>
                 </a:ln>
                 <a:solidFill>
@@ -1571,10 +1559,8 @@
               </a:lnSpc>
               <a:buNone/>
               <a:defRPr sz="2325" b="1" i="0">
-                <a:ln w="10478">
-                  <a:solidFill>
-                    <a:srgbClr val="071824"/>
-                  </a:solidFill>
+                <a:ln w="0">
+                  <a:noFill/>
                   <a:prstDash val="solid"/>
                 </a:ln>
                 <a:solidFill>
@@ -1587,10 +1573,8 @@
             </a:pPr>
             <a:r>
               <a:rPr sz="2325" b="1" i="0">
-                <a:ln w="10478">
-                  <a:solidFill>
-                    <a:srgbClr val="071824"/>
-                  </a:solidFill>
+                <a:ln w="0">
+                  <a:noFill/>
                   <a:prstDash val="solid"/>
                 </a:ln>
                 <a:solidFill>
@@ -1645,10 +1629,8 @@
               </a:lnSpc>
               <a:buNone/>
               <a:defRPr sz="1425" b="0" i="0">
-                <a:ln w="10478">
-                  <a:solidFill>
-                    <a:srgbClr val="071824"/>
-                  </a:solidFill>
+                <a:ln w="0">
+                  <a:noFill/>
                   <a:prstDash val="solid"/>
                 </a:ln>
                 <a:solidFill>
@@ -1661,10 +1643,8 @@
             </a:pPr>
             <a:r>
               <a:rPr sz="1425" b="0" i="0">
-                <a:ln w="10478">
-                  <a:solidFill>
-                    <a:srgbClr val="071824"/>
-                  </a:solidFill>
+                <a:ln w="0">
+                  <a:noFill/>
                   <a:prstDash val="solid"/>
                 </a:ln>
                 <a:solidFill>
@@ -1719,10 +1699,8 @@
               </a:lnSpc>
               <a:buNone/>
               <a:defRPr sz="1425" b="0" i="1">
-                <a:ln w="10478">
-                  <a:solidFill>
-                    <a:srgbClr val="071824"/>
-                  </a:solidFill>
+                <a:ln w="0">
+                  <a:noFill/>
                   <a:prstDash val="solid"/>
                 </a:ln>
                 <a:solidFill>
@@ -1735,10 +1713,8 @@
             </a:pPr>
             <a:r>
               <a:rPr sz="1425" b="0" i="1">
-                <a:ln w="10478">
-                  <a:solidFill>
-                    <a:srgbClr val="071824"/>
-                  </a:solidFill>
+                <a:ln w="0">
+                  <a:noFill/>
                   <a:prstDash val="solid"/>
                 </a:ln>
                 <a:solidFill>
@@ -1857,6 +1833,10 @@
               </a:lnSpc>
               <a:buNone/>
               <a:defRPr sz="975" b="0" i="0">
+                <a:ln w="0">
+                  <a:noFill/>
+                  <a:prstDash val="solid"/>
+                </a:ln>
                 <a:solidFill>
                   <a:srgbClr val="FFFFFF"/>
                 </a:solidFill>
@@ -1867,6 +1847,10 @@
             </a:pPr>
             <a:r>
               <a:rPr sz="975" b="0" i="0">
+                <a:ln w="0">
+                  <a:noFill/>
+                  <a:prstDash val="solid"/>
+                </a:ln>
                 <a:solidFill>
                   <a:srgbClr val="FFFFFF"/>
                 </a:solidFill>
@@ -1919,10 +1903,8 @@
               </a:lnSpc>
               <a:buNone/>
               <a:defRPr sz="1350" b="0" i="0">
-                <a:ln w="10478">
-                  <a:solidFill>
-                    <a:srgbClr val="071824"/>
-                  </a:solidFill>
+                <a:ln w="0">
+                  <a:noFill/>
                   <a:prstDash val="solid"/>
                 </a:ln>
                 <a:solidFill>
@@ -1935,10 +1917,8 @@
             </a:pPr>
             <a:r>
               <a:rPr sz="1350" b="0" i="0">
-                <a:ln w="10478">
-                  <a:solidFill>
-                    <a:srgbClr val="071824"/>
-                  </a:solidFill>
+                <a:ln w="0">
+                  <a:noFill/>
                   <a:prstDash val="solid"/>
                 </a:ln>
                 <a:solidFill>
@@ -1993,10 +1973,8 @@
               </a:lnSpc>
               <a:buNone/>
               <a:defRPr sz="1200" b="0" i="0">
-                <a:ln w="10478">
-                  <a:solidFill>
-                    <a:srgbClr val="071824"/>
-                  </a:solidFill>
+                <a:ln w="0">
+                  <a:noFill/>
                   <a:prstDash val="solid"/>
                 </a:ln>
                 <a:solidFill>
@@ -2009,10 +1987,8 @@
             </a:pPr>
             <a:r>
               <a:rPr sz="1200" b="0" i="0">
-                <a:ln w="10478">
-                  <a:solidFill>
-                    <a:srgbClr val="071824"/>
-                  </a:solidFill>
+                <a:ln w="0">
+                  <a:noFill/>
                   <a:prstDash val="solid"/>
                 </a:ln>
                 <a:solidFill>
@@ -2098,10 +2074,8 @@
               </a:lnSpc>
               <a:buNone/>
               <a:defRPr sz="1125" b="0" i="0">
-                <a:ln w="10478">
-                  <a:solidFill>
-                    <a:srgbClr val="071824"/>
-                  </a:solidFill>
+                <a:ln w="0">
+                  <a:noFill/>
                   <a:prstDash val="solid"/>
                 </a:ln>
                 <a:solidFill>
@@ -2114,10 +2088,8 @@
             </a:pPr>
             <a:r>
               <a:rPr sz="1125" b="0" i="0">
-                <a:ln w="10478">
-                  <a:solidFill>
-                    <a:srgbClr val="071824"/>
-                  </a:solidFill>
+                <a:ln w="0">
+                  <a:noFill/>
                   <a:prstDash val="solid"/>
                 </a:ln>
                 <a:solidFill>
@@ -2205,6 +2177,10 @@
               </a:lnSpc>
               <a:buNone/>
               <a:defRPr sz="975" b="0" i="0">
+                <a:ln w="0">
+                  <a:noFill/>
+                  <a:prstDash val="solid"/>
+                </a:ln>
                 <a:solidFill>
                   <a:srgbClr val="FFFFFF"/>
                 </a:solidFill>
@@ -2215,6 +2191,10 @@
             </a:pPr>
             <a:r>
               <a:rPr sz="975" b="0" i="0">
+                <a:ln w="0">
+                  <a:noFill/>
+                  <a:prstDash val="solid"/>
+                </a:ln>
                 <a:solidFill>
                   <a:srgbClr val="FFFFFF"/>
                 </a:solidFill>
@@ -2267,10 +2247,8 @@
               </a:lnSpc>
               <a:buNone/>
               <a:defRPr sz="1350" b="0" i="0">
-                <a:ln w="10478">
-                  <a:solidFill>
-                    <a:srgbClr val="071824"/>
-                  </a:solidFill>
+                <a:ln w="0">
+                  <a:noFill/>
                   <a:prstDash val="solid"/>
                 </a:ln>
                 <a:solidFill>
@@ -2283,10 +2261,8 @@
             </a:pPr>
             <a:r>
               <a:rPr sz="1350" b="0" i="0">
-                <a:ln w="10478">
-                  <a:solidFill>
-                    <a:srgbClr val="071824"/>
-                  </a:solidFill>
+                <a:ln w="0">
+                  <a:noFill/>
                   <a:prstDash val="solid"/>
                 </a:ln>
                 <a:solidFill>
@@ -2341,10 +2317,8 @@
               </a:lnSpc>
               <a:buNone/>
               <a:defRPr sz="1200" b="0" i="0">
-                <a:ln w="10478">
-                  <a:solidFill>
-                    <a:srgbClr val="071824"/>
-                  </a:solidFill>
+                <a:ln w="0">
+                  <a:noFill/>
                   <a:prstDash val="solid"/>
                 </a:ln>
                 <a:solidFill>
@@ -2357,10 +2331,8 @@
             </a:pPr>
             <a:r>
               <a:rPr sz="1200" b="0" i="0">
-                <a:ln w="10478">
-                  <a:solidFill>
-                    <a:srgbClr val="071824"/>
-                  </a:solidFill>
+                <a:ln w="0">
+                  <a:noFill/>
                   <a:prstDash val="solid"/>
                 </a:ln>
                 <a:solidFill>
@@ -2446,10 +2418,8 @@
               </a:lnSpc>
               <a:buNone/>
               <a:defRPr sz="1125" b="0" i="0">
-                <a:ln w="10478">
-                  <a:solidFill>
-                    <a:srgbClr val="071824"/>
-                  </a:solidFill>
+                <a:ln w="0">
+                  <a:noFill/>
                   <a:prstDash val="solid"/>
                 </a:ln>
                 <a:solidFill>
@@ -2462,10 +2432,8 @@
             </a:pPr>
             <a:r>
               <a:rPr sz="1125" b="0" i="0">
-                <a:ln w="10478">
-                  <a:solidFill>
-                    <a:srgbClr val="071824"/>
-                  </a:solidFill>
+                <a:ln w="0">
+                  <a:noFill/>
                   <a:prstDash val="solid"/>
                 </a:ln>
                 <a:solidFill>
@@ -2553,6 +2521,10 @@
               </a:lnSpc>
               <a:buNone/>
               <a:defRPr sz="975" b="0" i="0">
+                <a:ln w="0">
+                  <a:noFill/>
+                  <a:prstDash val="solid"/>
+                </a:ln>
                 <a:solidFill>
                   <a:srgbClr val="FFFFFF"/>
                 </a:solidFill>
@@ -2563,6 +2535,10 @@
             </a:pPr>
             <a:r>
               <a:rPr sz="975" b="0" i="0">
+                <a:ln w="0">
+                  <a:noFill/>
+                  <a:prstDash val="solid"/>
+                </a:ln>
                 <a:solidFill>
                   <a:srgbClr val="FFFFFF"/>
                 </a:solidFill>
@@ -2615,10 +2591,8 @@
               </a:lnSpc>
               <a:buNone/>
               <a:defRPr sz="1350" b="0" i="0">
-                <a:ln w="10478">
-                  <a:solidFill>
-                    <a:srgbClr val="071824"/>
-                  </a:solidFill>
+                <a:ln w="0">
+                  <a:noFill/>
                   <a:prstDash val="solid"/>
                 </a:ln>
                 <a:solidFill>
@@ -2631,10 +2605,8 @@
             </a:pPr>
             <a:r>
               <a:rPr sz="1350" b="0" i="0">
-                <a:ln w="10478">
-                  <a:solidFill>
-                    <a:srgbClr val="071824"/>
-                  </a:solidFill>
+                <a:ln w="0">
+                  <a:noFill/>
                   <a:prstDash val="solid"/>
                 </a:ln>
                 <a:solidFill>
@@ -2689,10 +2661,8 @@
               </a:lnSpc>
               <a:buNone/>
               <a:defRPr sz="1200" b="0" i="0">
-                <a:ln w="10478">
-                  <a:solidFill>
-                    <a:srgbClr val="071824"/>
-                  </a:solidFill>
+                <a:ln w="0">
+                  <a:noFill/>
                   <a:prstDash val="solid"/>
                 </a:ln>
                 <a:solidFill>
@@ -2705,10 +2675,8 @@
             </a:pPr>
             <a:r>
               <a:rPr sz="1200" b="0" i="0">
-                <a:ln w="10478">
-                  <a:solidFill>
-                    <a:srgbClr val="071824"/>
-                  </a:solidFill>
+                <a:ln w="0">
+                  <a:noFill/>
                   <a:prstDash val="solid"/>
                 </a:ln>
                 <a:solidFill>
@@ -2794,10 +2762,8 @@
               </a:lnSpc>
               <a:buNone/>
               <a:defRPr sz="1125" b="0" i="0">
-                <a:ln w="10478">
-                  <a:solidFill>
-                    <a:srgbClr val="071824"/>
-                  </a:solidFill>
+                <a:ln w="0">
+                  <a:noFill/>
                   <a:prstDash val="solid"/>
                 </a:ln>
                 <a:solidFill>
@@ -2810,10 +2776,8 @@
             </a:pPr>
             <a:r>
               <a:rPr sz="1125" b="0" i="0">
-                <a:ln w="10478">
-                  <a:solidFill>
-                    <a:srgbClr val="071824"/>
-                  </a:solidFill>
+                <a:ln w="0">
+                  <a:noFill/>
                   <a:prstDash val="solid"/>
                 </a:ln>
                 <a:solidFill>
@@ -2901,6 +2865,10 @@
               </a:lnSpc>
               <a:buNone/>
               <a:defRPr sz="975" b="0" i="0">
+                <a:ln w="0">
+                  <a:noFill/>
+                  <a:prstDash val="solid"/>
+                </a:ln>
                 <a:solidFill>
                   <a:srgbClr val="FFFFFF"/>
                 </a:solidFill>
@@ -2911,6 +2879,10 @@
             </a:pPr>
             <a:r>
               <a:rPr sz="975" b="0" i="0">
+                <a:ln w="0">
+                  <a:noFill/>
+                  <a:prstDash val="solid"/>
+                </a:ln>
                 <a:solidFill>
                   <a:srgbClr val="FFFFFF"/>
                 </a:solidFill>
@@ -2963,10 +2935,8 @@
               </a:lnSpc>
               <a:buNone/>
               <a:defRPr sz="1350" b="0" i="0">
-                <a:ln w="10478">
-                  <a:solidFill>
-                    <a:srgbClr val="071824"/>
-                  </a:solidFill>
+                <a:ln w="0">
+                  <a:noFill/>
                   <a:prstDash val="solid"/>
                 </a:ln>
                 <a:solidFill>
@@ -2979,10 +2949,8 @@
             </a:pPr>
             <a:r>
               <a:rPr sz="1350" b="0" i="0">
-                <a:ln w="10478">
-                  <a:solidFill>
-                    <a:srgbClr val="071824"/>
-                  </a:solidFill>
+                <a:ln w="0">
+                  <a:noFill/>
                   <a:prstDash val="solid"/>
                 </a:ln>
                 <a:solidFill>
@@ -3037,10 +3005,8 @@
               </a:lnSpc>
               <a:buNone/>
               <a:defRPr sz="1200" b="0" i="0">
-                <a:ln w="10478">
-                  <a:solidFill>
-                    <a:srgbClr val="071824"/>
-                  </a:solidFill>
+                <a:ln w="0">
+                  <a:noFill/>
                   <a:prstDash val="solid"/>
                 </a:ln>
                 <a:solidFill>
@@ -3053,10 +3019,8 @@
             </a:pPr>
             <a:r>
               <a:rPr sz="1200" b="0" i="0">
-                <a:ln w="10478">
-                  <a:solidFill>
-                    <a:srgbClr val="071824"/>
-                  </a:solidFill>
+                <a:ln w="0">
+                  <a:noFill/>
                   <a:prstDash val="solid"/>
                 </a:ln>
                 <a:solidFill>
@@ -3142,10 +3106,8 @@
               </a:lnSpc>
               <a:buNone/>
               <a:defRPr sz="1125" b="0" i="0">
-                <a:ln w="10478">
-                  <a:solidFill>
-                    <a:srgbClr val="071824"/>
-                  </a:solidFill>
+                <a:ln w="0">
+                  <a:noFill/>
                   <a:prstDash val="solid"/>
                 </a:ln>
                 <a:solidFill>
@@ -3158,10 +3120,8 @@
             </a:pPr>
             <a:r>
               <a:rPr sz="1125" b="0" i="0">
-                <a:ln w="10478">
-                  <a:solidFill>
-                    <a:srgbClr val="071824"/>
-                  </a:solidFill>
+                <a:ln w="0">
+                  <a:noFill/>
                   <a:prstDash val="solid"/>
                 </a:ln>
                 <a:solidFill>
@@ -3249,6 +3209,10 @@
               </a:lnSpc>
               <a:buNone/>
               <a:defRPr sz="975" b="0" i="0">
+                <a:ln w="0">
+                  <a:noFill/>
+                  <a:prstDash val="solid"/>
+                </a:ln>
                 <a:solidFill>
                   <a:srgbClr val="FFFFFF"/>
                 </a:solidFill>
@@ -3259,6 +3223,10 @@
             </a:pPr>
             <a:r>
               <a:rPr sz="975" b="0" i="0">
+                <a:ln w="0">
+                  <a:noFill/>
+                  <a:prstDash val="solid"/>
+                </a:ln>
                 <a:solidFill>
                   <a:srgbClr val="FFFFFF"/>
                 </a:solidFill>
@@ -3311,10 +3279,8 @@
               </a:lnSpc>
               <a:buNone/>
               <a:defRPr sz="1350" b="0" i="0">
-                <a:ln w="10478">
-                  <a:solidFill>
-                    <a:srgbClr val="071824"/>
-                  </a:solidFill>
+                <a:ln w="0">
+                  <a:noFill/>
                   <a:prstDash val="solid"/>
                 </a:ln>
                 <a:solidFill>
@@ -3327,10 +3293,8 @@
             </a:pPr>
             <a:r>
               <a:rPr sz="1350" b="0" i="0">
-                <a:ln w="10478">
-                  <a:solidFill>
-                    <a:srgbClr val="071824"/>
-                  </a:solidFill>
+                <a:ln w="0">
+                  <a:noFill/>
                   <a:prstDash val="solid"/>
                 </a:ln>
                 <a:solidFill>
@@ -3385,10 +3349,8 @@
               </a:lnSpc>
               <a:buNone/>
               <a:defRPr sz="1200" b="0" i="0">
-                <a:ln w="10478">
-                  <a:solidFill>
-                    <a:srgbClr val="071824"/>
-                  </a:solidFill>
+                <a:ln w="0">
+                  <a:noFill/>
                   <a:prstDash val="solid"/>
                 </a:ln>
                 <a:solidFill>
@@ -3401,10 +3363,8 @@
             </a:pPr>
             <a:r>
               <a:rPr sz="1200" b="0" i="0">
-                <a:ln w="10478">
-                  <a:solidFill>
-                    <a:srgbClr val="071824"/>
-                  </a:solidFill>
+                <a:ln w="0">
+                  <a:noFill/>
                   <a:prstDash val="solid"/>
                 </a:ln>
                 <a:solidFill>
@@ -3490,10 +3450,8 @@
               </a:lnSpc>
               <a:buNone/>
               <a:defRPr sz="1125" b="0" i="0">
-                <a:ln w="10478">
-                  <a:solidFill>
-                    <a:srgbClr val="071824"/>
-                  </a:solidFill>
+                <a:ln w="0">
+                  <a:noFill/>
                   <a:prstDash val="solid"/>
                 </a:ln>
                 <a:solidFill>
@@ -3506,10 +3464,8 @@
             </a:pPr>
             <a:r>
               <a:rPr sz="1125" b="0" i="0">
-                <a:ln w="10478">
-                  <a:solidFill>
-                    <a:srgbClr val="071824"/>
-                  </a:solidFill>
+                <a:ln w="0">
+                  <a:noFill/>
                   <a:prstDash val="solid"/>
                 </a:ln>
                 <a:solidFill>
@@ -3564,6 +3520,10 @@
               </a:lnSpc>
               <a:buNone/>
               <a:defRPr sz="900" b="0" i="0">
+                <a:ln w="0">
+                  <a:noFill/>
+                  <a:prstDash val="solid"/>
+                </a:ln>
                 <a:solidFill>
                   <a:srgbClr val="F5F0E7"/>
                 </a:solidFill>
@@ -3574,6 +3534,10 @@
             </a:pPr>
             <a:r>
               <a:rPr sz="900" b="0" i="0">
+                <a:ln w="0">
+                  <a:noFill/>
+                  <a:prstDash val="solid"/>
+                </a:ln>
                 <a:solidFill>
                   <a:srgbClr val="F5F0E7"/>
                 </a:solidFill>

</xml_diff>